<commit_message>
Refactor code structure for improved readability and maintainability
</commit_message>
<xml_diff>
--- a/Documentation/E-Commerce-Product-Management-System.pptx
+++ b/Documentation/E-Commerce-Product-Management-System.pptx
@@ -2574,6 +2574,37 @@
               </a:lnSpc>
               <a:buNone/>
             </a:pPr>
+            <a:endParaRPr lang="en-US" sz="1850" dirty="0"/>
+          </a:p>
+        </p:txBody>
+      </p:sp>
+      <p:sp>
+        <p:nvSpPr>
+          <p:cNvPr id="6" name="Text 2"/>
+          <p:cNvSpPr/>
+          <p:nvPr/>
+        </p:nvSpPr>
+        <p:spPr>
+          <a:xfrm>
+            <a:off x="837724" y="4806791"/>
+            <a:ext cx="7468553" cy="383024"/>
+          </a:xfrm>
+          <a:prstGeom prst="rect">
+            <a:avLst/>
+          </a:prstGeom>
+          <a:noFill/>
+          <a:ln/>
+        </p:spPr>
+        <p:txBody>
+          <a:bodyPr wrap="none" lIns="0" tIns="0" rIns="0" bIns="0" rtlCol="0" anchor="t"/>
+          <a:lstStyle/>
+          <a:p>
+            <a:pPr marL="0" indent="0" algn="l">
+              <a:lnSpc>
+                <a:spcPts val="3000"/>
+              </a:lnSpc>
+              <a:buNone/>
+            </a:pPr>
             <a:r>
               <a:rPr lang="en-US" sz="1850" dirty="0">
                 <a:solidFill>
@@ -2583,41 +2614,10 @@
                 <a:ea typeface="Martel Sans Light" pitchFamily="34" charset="-122"/>
                 <a:cs typeface="Martel Sans Light" pitchFamily="34" charset="-120"/>
               </a:rPr>
-              <a:t>Sprint Evaluation Presentation</a:t>
-            </a:r>
-            <a:endParaRPr lang="en-US" sz="1850" dirty="0"/>
-          </a:p>
-        </p:txBody>
-      </p:sp>
-      <p:sp>
-        <p:nvSpPr>
-          <p:cNvPr id="6" name="Text 2"/>
-          <p:cNvSpPr/>
-          <p:nvPr/>
-        </p:nvSpPr>
-        <p:spPr>
-          <a:xfrm>
-            <a:off x="837724" y="4806791"/>
-            <a:ext cx="7468553" cy="383024"/>
-          </a:xfrm>
-          <a:prstGeom prst="rect">
-            <a:avLst/>
-          </a:prstGeom>
-          <a:noFill/>
-          <a:ln/>
-        </p:spPr>
-        <p:txBody>
-          <a:bodyPr wrap="none" lIns="0" tIns="0" rIns="0" bIns="0" rtlCol="0" anchor="t"/>
-          <a:lstStyle/>
-          <a:p>
-            <a:pPr marL="0" indent="0" algn="l">
-              <a:lnSpc>
-                <a:spcPts val="3000"/>
-              </a:lnSpc>
-              <a:buNone/>
-            </a:pPr>
-            <a:r>
-              <a:rPr lang="en-US" sz="1850" dirty="0">
+              <a:t>Student Name: </a:t>
+            </a:r>
+            <a:r>
+              <a:rPr lang="en-US" sz="1850" b="1" dirty="0">
                 <a:solidFill>
                   <a:srgbClr val="D9E1FF"/>
                 </a:solidFill>
@@ -2625,17 +2625,6 @@
                 <a:ea typeface="Martel Sans Light" pitchFamily="34" charset="-122"/>
                 <a:cs typeface="Martel Sans Light" pitchFamily="34" charset="-120"/>
               </a:rPr>
-              <a:t>Student Name: </a:t>
-            </a:r>
-            <a:r>
-              <a:rPr lang="en-US" sz="1850" b="1" dirty="0">
-                <a:solidFill>
-                  <a:srgbClr val="D9E1FF"/>
-                </a:solidFill>
-                <a:latin typeface="Martel Sans Light" pitchFamily="34" charset="0"/>
-                <a:ea typeface="Martel Sans Light" pitchFamily="34" charset="-122"/>
-                <a:cs typeface="Martel Sans Light" pitchFamily="34" charset="-120"/>
-              </a:rPr>
               <a:t>Abhinandan Sah</a:t>
             </a:r>
             <a:endParaRPr lang="en-US" sz="1850" dirty="0"/>
@@ -2669,28 +2658,6 @@
               </a:lnSpc>
               <a:buNone/>
             </a:pPr>
-            <a:r>
-              <a:rPr lang="en-US" sz="1850" dirty="0">
-                <a:solidFill>
-                  <a:srgbClr val="D9E1FF"/>
-                </a:solidFill>
-                <a:latin typeface="Martel Sans Light" pitchFamily="34" charset="0"/>
-                <a:ea typeface="Martel Sans Light" pitchFamily="34" charset="-122"/>
-                <a:cs typeface="Martel Sans Light" pitchFamily="34" charset="-120"/>
-              </a:rPr>
-              <a:t>Date: </a:t>
-            </a:r>
-            <a:r>
-              <a:rPr lang="en-US" sz="1850" b="1" dirty="0">
-                <a:solidFill>
-                  <a:srgbClr val="D9E1FF"/>
-                </a:solidFill>
-                <a:latin typeface="Martel Sans Light" pitchFamily="34" charset="0"/>
-                <a:ea typeface="Martel Sans Light" pitchFamily="34" charset="-122"/>
-                <a:cs typeface="Martel Sans Light" pitchFamily="34" charset="-120"/>
-              </a:rPr>
-              <a:t>05-05-2026</a:t>
-            </a:r>
             <a:endParaRPr lang="en-US" sz="1850" dirty="0"/>
           </a:p>
         </p:txBody>
@@ -4075,7 +4042,7 @@
                 <a:ea typeface="Martel Sans Light" pitchFamily="34" charset="-122"/>
                 <a:cs typeface="Martel Sans Light" pitchFamily="34" charset="-120"/>
               </a:rPr>
-              <a:t>Media asset handling and SKU generation</a:t>
+              <a:t>Media asset handling </a:t>
             </a:r>
             <a:endParaRPr lang="en-US" sz="1600" dirty="0"/>
           </a:p>
@@ -4138,7 +4105,7 @@
                 <a:ea typeface="Martel Sans Light" pitchFamily="34" charset="-122"/>
                 <a:cs typeface="Martel Sans Light" pitchFamily="34" charset="-120"/>
               </a:rPr>
-              <a:t>Dashboard KPIs and audit trail</a:t>
+              <a:t>Dashboard and audit trail</a:t>
             </a:r>
             <a:endParaRPr lang="en-US" sz="1600" dirty="0"/>
           </a:p>
@@ -10224,7 +10191,7 @@
                 <a:ea typeface="Martel Sans Light" pitchFamily="34" charset="-122"/>
                 <a:cs typeface="Martel Sans Light" pitchFamily="34" charset="-120"/>
               </a:rPr>
-              <a:t>Integration tests for repositories and controllers</a:t>
+              <a:t>Tests for repositories and controllers</a:t>
             </a:r>
             <a:endParaRPr lang="en-US" sz="1850" dirty="0"/>
           </a:p>

</xml_diff>